<commit_message>
Update PowerPoint for song #256 in FUBC - Українські
</commit_message>
<xml_diff>
--- a/fubc-ua/256-Маю в серці палке бажання (Пісні Спасенних №255).pptx
+++ b/fubc-ua/256-Маю в серці палке бажання (Пісні Спасенних №255).pptx
@@ -775,7 +775,7 @@
           <a:p>
             <a:r>
               <a:rPr lang="en-US" dirty="0"/>
-              <a:t>P · 1/1 · rows:2,2,2,1</a:t>
+              <a:t>P · 1/1</a:t>
             </a:r>
             <a:endParaRPr lang="en-US" dirty="0"/>
           </a:p>
@@ -951,7 +951,7 @@
           <a:p>
             <a:r>
               <a:rPr lang="en-US" dirty="0"/>
-              <a:t>P · 1/1 · rows:2,2,2,1</a:t>
+              <a:t>P · 1/1</a:t>
             </a:r>
             <a:endParaRPr lang="en-US" dirty="0"/>
           </a:p>
@@ -1127,7 +1127,7 @@
           <a:p>
             <a:r>
               <a:rPr lang="en-US" dirty="0"/>
-              <a:t>P · 1/1 · rows:2,2,2,1</a:t>
+              <a:t>P · 1/1</a:t>
             </a:r>
             <a:endParaRPr lang="en-US" dirty="0"/>
           </a:p>
@@ -1303,7 +1303,7 @@
           <a:p>
             <a:r>
               <a:rPr lang="en-US" dirty="0"/>
-              <a:t>P · 1/1 · rows:2,2,2,1</a:t>
+              <a:t>P · 1/1</a:t>
             </a:r>
             <a:endParaRPr lang="en-US" dirty="0"/>
           </a:p>
@@ -1951,7 +1951,7 @@
                 <a:ea typeface="Arial" pitchFamily="34" charset="-122"/>
                 <a:cs typeface="Arial" pitchFamily="34" charset="-120"/>
               </a:rPr>
-              <a:t>Одного (одного),</a:t>
+              <a:t>Одного, Боже мій,</a:t>
             </a:r>
             <a:endParaRPr lang="en-US" sz="5200" dirty="0"/>
           </a:p>
@@ -1968,7 +1968,7 @@
                 <a:ea typeface="Arial" pitchFamily="34" charset="-122"/>
                 <a:cs typeface="Arial" pitchFamily="34" charset="-120"/>
               </a:rPr>
-              <a:t>Боже мій (Боже мій),</a:t>
+              <a:t>у житті прагну я.</a:t>
             </a:r>
             <a:endParaRPr lang="en-US" sz="5200" dirty="0"/>
           </a:p>
@@ -1985,58 +1985,7 @@
                 <a:ea typeface="Arial" pitchFamily="34" charset="-122"/>
                 <a:cs typeface="Arial" pitchFamily="34" charset="-120"/>
               </a:rPr>
-              <a:t>у житті (у житті)</a:t>
-            </a:r>
-            <a:endParaRPr lang="en-US" sz="5200" dirty="0"/>
-          </a:p>
-          <a:p>
-            <a:pPr algn="ctr" indent="0" marL="0">
-              <a:buNone/>
-            </a:pPr>
-            <a:r>
-              <a:rPr lang="en-US" sz="5200" b="1" i="1" dirty="0">
-                <a:solidFill>
-                  <a:srgbClr val="FFFFFF"/>
-                </a:solidFill>
-                <a:latin typeface="Arial" pitchFamily="34" charset="0"/>
-                <a:ea typeface="Arial" pitchFamily="34" charset="-122"/>
-                <a:cs typeface="Arial" pitchFamily="34" charset="-120"/>
-              </a:rPr>
-              <a:t>прагну я (прагну я).</a:t>
-            </a:r>
-            <a:endParaRPr lang="en-US" sz="5200" dirty="0"/>
-          </a:p>
-          <a:p>
-            <a:pPr algn="ctr" indent="0" marL="0">
-              <a:buNone/>
-            </a:pPr>
-            <a:r>
-              <a:rPr lang="en-US" sz="5200" b="1" i="1" dirty="0">
-                <a:solidFill>
-                  <a:srgbClr val="FFFFFF"/>
-                </a:solidFill>
-                <a:latin typeface="Arial" pitchFamily="34" charset="0"/>
-                <a:ea typeface="Arial" pitchFamily="34" charset="-122"/>
-                <a:cs typeface="Arial" pitchFamily="34" charset="-120"/>
-              </a:rPr>
-              <a:t>Одного (одного)</a:t>
-            </a:r>
-            <a:endParaRPr lang="en-US" sz="5200" dirty="0"/>
-          </a:p>
-          <a:p>
-            <a:pPr algn="ctr" indent="0" marL="0">
-              <a:buNone/>
-            </a:pPr>
-            <a:r>
-              <a:rPr lang="en-US" sz="5200" b="1" i="1" dirty="0">
-                <a:solidFill>
-                  <a:srgbClr val="FFFFFF"/>
-                </a:solidFill>
-                <a:latin typeface="Arial" pitchFamily="34" charset="0"/>
-                <a:ea typeface="Arial" pitchFamily="34" charset="-122"/>
-                <a:cs typeface="Arial" pitchFamily="34" charset="-120"/>
-              </a:rPr>
-              <a:t>прагну я (прагну я):</a:t>
+              <a:t>Одного прагну я:</a:t>
             </a:r>
             <a:endParaRPr lang="en-US" sz="5200" dirty="0"/>
           </a:p>
@@ -2246,7 +2195,7 @@
                 <a:ea typeface="Arial" pitchFamily="34" charset="-122"/>
                 <a:cs typeface="Arial" pitchFamily="34" charset="-120"/>
               </a:rPr>
-              <a:t>Одного (одного),</a:t>
+              <a:t>Одного, Боже мій,</a:t>
             </a:r>
             <a:endParaRPr lang="en-US" sz="5200" dirty="0"/>
           </a:p>
@@ -2263,7 +2212,7 @@
                 <a:ea typeface="Arial" pitchFamily="34" charset="-122"/>
                 <a:cs typeface="Arial" pitchFamily="34" charset="-120"/>
               </a:rPr>
-              <a:t>Боже мій (Боже мій),</a:t>
+              <a:t>у житті прагну я.</a:t>
             </a:r>
             <a:endParaRPr lang="en-US" sz="5200" dirty="0"/>
           </a:p>
@@ -2280,58 +2229,7 @@
                 <a:ea typeface="Arial" pitchFamily="34" charset="-122"/>
                 <a:cs typeface="Arial" pitchFamily="34" charset="-120"/>
               </a:rPr>
-              <a:t>у житті (у житті)</a:t>
-            </a:r>
-            <a:endParaRPr lang="en-US" sz="5200" dirty="0"/>
-          </a:p>
-          <a:p>
-            <a:pPr algn="ctr" indent="0" marL="0">
-              <a:buNone/>
-            </a:pPr>
-            <a:r>
-              <a:rPr lang="en-US" sz="5200" b="1" i="1" dirty="0">
-                <a:solidFill>
-                  <a:srgbClr val="FFFFFF"/>
-                </a:solidFill>
-                <a:latin typeface="Arial" pitchFamily="34" charset="0"/>
-                <a:ea typeface="Arial" pitchFamily="34" charset="-122"/>
-                <a:cs typeface="Arial" pitchFamily="34" charset="-120"/>
-              </a:rPr>
-              <a:t>прагну я (прагну я).</a:t>
-            </a:r>
-            <a:endParaRPr lang="en-US" sz="5200" dirty="0"/>
-          </a:p>
-          <a:p>
-            <a:pPr algn="ctr" indent="0" marL="0">
-              <a:buNone/>
-            </a:pPr>
-            <a:r>
-              <a:rPr lang="en-US" sz="5200" b="1" i="1" dirty="0">
-                <a:solidFill>
-                  <a:srgbClr val="FFFFFF"/>
-                </a:solidFill>
-                <a:latin typeface="Arial" pitchFamily="34" charset="0"/>
-                <a:ea typeface="Arial" pitchFamily="34" charset="-122"/>
-                <a:cs typeface="Arial" pitchFamily="34" charset="-120"/>
-              </a:rPr>
-              <a:t>Одного (одного)</a:t>
-            </a:r>
-            <a:endParaRPr lang="en-US" sz="5200" dirty="0"/>
-          </a:p>
-          <a:p>
-            <a:pPr algn="ctr" indent="0" marL="0">
-              <a:buNone/>
-            </a:pPr>
-            <a:r>
-              <a:rPr lang="en-US" sz="5200" b="1" i="1" dirty="0">
-                <a:solidFill>
-                  <a:srgbClr val="FFFFFF"/>
-                </a:solidFill>
-                <a:latin typeface="Arial" pitchFamily="34" charset="0"/>
-                <a:ea typeface="Arial" pitchFamily="34" charset="-122"/>
-                <a:cs typeface="Arial" pitchFamily="34" charset="-120"/>
-              </a:rPr>
-              <a:t>прагну я (прагну я):</a:t>
+              <a:t>Одного прагну я:</a:t>
             </a:r>
             <a:endParaRPr lang="en-US" sz="5200" dirty="0"/>
           </a:p>
@@ -2541,7 +2439,7 @@
                 <a:ea typeface="Arial" pitchFamily="34" charset="-122"/>
                 <a:cs typeface="Arial" pitchFamily="34" charset="-120"/>
               </a:rPr>
-              <a:t>Одного (одного),</a:t>
+              <a:t>Одного, Боже мій,</a:t>
             </a:r>
             <a:endParaRPr lang="en-US" sz="5200" dirty="0"/>
           </a:p>
@@ -2558,7 +2456,7 @@
                 <a:ea typeface="Arial" pitchFamily="34" charset="-122"/>
                 <a:cs typeface="Arial" pitchFamily="34" charset="-120"/>
               </a:rPr>
-              <a:t>Боже мій (Боже мій),</a:t>
+              <a:t>у житті прагну я.</a:t>
             </a:r>
             <a:endParaRPr lang="en-US" sz="5200" dirty="0"/>
           </a:p>
@@ -2575,58 +2473,7 @@
                 <a:ea typeface="Arial" pitchFamily="34" charset="-122"/>
                 <a:cs typeface="Arial" pitchFamily="34" charset="-120"/>
               </a:rPr>
-              <a:t>у житті (у житті)</a:t>
-            </a:r>
-            <a:endParaRPr lang="en-US" sz="5200" dirty="0"/>
-          </a:p>
-          <a:p>
-            <a:pPr algn="ctr" indent="0" marL="0">
-              <a:buNone/>
-            </a:pPr>
-            <a:r>
-              <a:rPr lang="en-US" sz="5200" b="1" i="1" dirty="0">
-                <a:solidFill>
-                  <a:srgbClr val="FFFFFF"/>
-                </a:solidFill>
-                <a:latin typeface="Arial" pitchFamily="34" charset="0"/>
-                <a:ea typeface="Arial" pitchFamily="34" charset="-122"/>
-                <a:cs typeface="Arial" pitchFamily="34" charset="-120"/>
-              </a:rPr>
-              <a:t>прагну я (прагну я).</a:t>
-            </a:r>
-            <a:endParaRPr lang="en-US" sz="5200" dirty="0"/>
-          </a:p>
-          <a:p>
-            <a:pPr algn="ctr" indent="0" marL="0">
-              <a:buNone/>
-            </a:pPr>
-            <a:r>
-              <a:rPr lang="en-US" sz="5200" b="1" i="1" dirty="0">
-                <a:solidFill>
-                  <a:srgbClr val="FFFFFF"/>
-                </a:solidFill>
-                <a:latin typeface="Arial" pitchFamily="34" charset="0"/>
-                <a:ea typeface="Arial" pitchFamily="34" charset="-122"/>
-                <a:cs typeface="Arial" pitchFamily="34" charset="-120"/>
-              </a:rPr>
-              <a:t>Одного (одного)</a:t>
-            </a:r>
-            <a:endParaRPr lang="en-US" sz="5200" dirty="0"/>
-          </a:p>
-          <a:p>
-            <a:pPr algn="ctr" indent="0" marL="0">
-              <a:buNone/>
-            </a:pPr>
-            <a:r>
-              <a:rPr lang="en-US" sz="5200" b="1" i="1" dirty="0">
-                <a:solidFill>
-                  <a:srgbClr val="FFFFFF"/>
-                </a:solidFill>
-                <a:latin typeface="Arial" pitchFamily="34" charset="0"/>
-                <a:ea typeface="Arial" pitchFamily="34" charset="-122"/>
-                <a:cs typeface="Arial" pitchFamily="34" charset="-120"/>
-              </a:rPr>
-              <a:t>прагну я (прагну я):</a:t>
+              <a:t>Одного прагну я:</a:t>
             </a:r>
             <a:endParaRPr lang="en-US" sz="5200" dirty="0"/>
           </a:p>
@@ -2836,7 +2683,7 @@
                 <a:ea typeface="Arial" pitchFamily="34" charset="-122"/>
                 <a:cs typeface="Arial" pitchFamily="34" charset="-120"/>
               </a:rPr>
-              <a:t>Одного (одного),</a:t>
+              <a:t>Одного, Боже мій,</a:t>
             </a:r>
             <a:endParaRPr lang="en-US" sz="5200" dirty="0"/>
           </a:p>
@@ -2853,7 +2700,7 @@
                 <a:ea typeface="Arial" pitchFamily="34" charset="-122"/>
                 <a:cs typeface="Arial" pitchFamily="34" charset="-120"/>
               </a:rPr>
-              <a:t>Боже мій (Боже мій),</a:t>
+              <a:t>у житті прагну я.</a:t>
             </a:r>
             <a:endParaRPr lang="en-US" sz="5200" dirty="0"/>
           </a:p>
@@ -2870,58 +2717,7 @@
                 <a:ea typeface="Arial" pitchFamily="34" charset="-122"/>
                 <a:cs typeface="Arial" pitchFamily="34" charset="-120"/>
               </a:rPr>
-              <a:t>у житті (у житті)</a:t>
-            </a:r>
-            <a:endParaRPr lang="en-US" sz="5200" dirty="0"/>
-          </a:p>
-          <a:p>
-            <a:pPr algn="ctr" indent="0" marL="0">
-              <a:buNone/>
-            </a:pPr>
-            <a:r>
-              <a:rPr lang="en-US" sz="5200" b="1" i="1" dirty="0">
-                <a:solidFill>
-                  <a:srgbClr val="FFFFFF"/>
-                </a:solidFill>
-                <a:latin typeface="Arial" pitchFamily="34" charset="0"/>
-                <a:ea typeface="Arial" pitchFamily="34" charset="-122"/>
-                <a:cs typeface="Arial" pitchFamily="34" charset="-120"/>
-              </a:rPr>
-              <a:t>прагну я (прагну я).</a:t>
-            </a:r>
-            <a:endParaRPr lang="en-US" sz="5200" dirty="0"/>
-          </a:p>
-          <a:p>
-            <a:pPr algn="ctr" indent="0" marL="0">
-              <a:buNone/>
-            </a:pPr>
-            <a:r>
-              <a:rPr lang="en-US" sz="5200" b="1" i="1" dirty="0">
-                <a:solidFill>
-                  <a:srgbClr val="FFFFFF"/>
-                </a:solidFill>
-                <a:latin typeface="Arial" pitchFamily="34" charset="0"/>
-                <a:ea typeface="Arial" pitchFamily="34" charset="-122"/>
-                <a:cs typeface="Arial" pitchFamily="34" charset="-120"/>
-              </a:rPr>
-              <a:t>Одного (одного)</a:t>
-            </a:r>
-            <a:endParaRPr lang="en-US" sz="5200" dirty="0"/>
-          </a:p>
-          <a:p>
-            <a:pPr algn="ctr" indent="0" marL="0">
-              <a:buNone/>
-            </a:pPr>
-            <a:r>
-              <a:rPr lang="en-US" sz="5200" b="1" i="1" dirty="0">
-                <a:solidFill>
-                  <a:srgbClr val="FFFFFF"/>
-                </a:solidFill>
-                <a:latin typeface="Arial" pitchFamily="34" charset="0"/>
-                <a:ea typeface="Arial" pitchFamily="34" charset="-122"/>
-                <a:cs typeface="Arial" pitchFamily="34" charset="-120"/>
-              </a:rPr>
-              <a:t>прагну я (прагну я):</a:t>
+              <a:t>Одного прагну я:</a:t>
             </a:r>
             <a:endParaRPr lang="en-US" sz="5200" dirty="0"/>
           </a:p>

</xml_diff>